<commit_message>
Notebook exécuté final et red teaming chiffré dans le deck
Co-Authored-By: Claude Opus 5.5 <noreply@anthropic.com>
Claude-Session: https://claude.ai/code/session_01UCGFQJa1BSGZjUWmrq2bhv
</commit_message>
<xml_diff>
--- a/soutenance/Ethics_of_AI_Soutenance.pptx
+++ b/soutenance/Ethics_of_AI_Soutenance.pptx
@@ -119,7 +119,7 @@
   <p:extLst>
     <p:ext uri="{521415D9-36F7-43E2-AB2F-B90AF26B5E84}">
       <p14:sectionLst xmlns:p14="http://schemas.microsoft.com/office/powerpoint/2010/main">
-        <p14:section name="Contexte et biais" id="{57db8ce7-a9e5-d584-45d7-225c39112e5f}">
+        <p14:section name="Contexte et biais" id="{278a6a5d-ffab-3ec4-52ca-eef3baca5c36}">
           <p14:sldIdLst>
             <p14:sldId id="256"/>
             <p14:sldId id="257"/>
@@ -127,7 +127,7 @@
             <p14:sldId id="259"/>
           </p14:sldIdLst>
         </p14:section>
-        <p14:section name="Méthode" id="{6b967334-9f6a-1ef7-ca06-d19c307536d1}">
+        <p14:section name="Méthode" id="{f9172eae-1a56-004d-234c-23e764931d85}">
           <p14:sldIdLst>
             <p14:sldId id="260"/>
             <p14:sldId id="261"/>
@@ -136,7 +136,7 @@
             <p14:sldId id="264"/>
           </p14:sldIdLst>
         </p14:section>
-        <p14:section name="Démo et limites" id="{e185050b-b355-42f0-8ed0-f483cb4fab84}">
+        <p14:section name="Démo et limites" id="{81f9511e-cfd0-fd67-7acf-e4bf811c4624}">
           <p14:sldIdLst>
             <p14:sldId id="265"/>
             <p14:sldId id="266"/>
@@ -812,7 +812,7 @@
           <a:p>
             <a:r>
               <a:rPr lang="en-US" dirty="0"/>
-              <a:t>MATHIS (40 s). On a joué l'adversaire : injection de texte dans le profil, et proxy en plaçant le joueur dans un club brésilien. Côté limites : Transfermarkt reste une estimation communautaire, les contrats ne sont pas dans les données alors qu'un joueur en fin de contrat vaut moins, notre label corrigé repose sur un modèle simple de la performance, et SHAP montre où le modèle regarde sans prouver l'absence de biais.</a:t>
+              <a:t>MATHIS (40 s). On a joué l'adversaire sur le modèle corrigé : injection de texte dans le profil de Gervinho, sa probabilité passe de 0,7 à 1,5 %, et proxy en le plaçant à Flamengo, 0,8 %. Le modèle ne se laisse pas manipuler. Côté limites : Transfermarkt reste une estimation communautaire, les contrats ne sont pas dans les données alors qu'un joueur en fin de contrat vaut moins, notre label corrigé repose sur un modèle simple de la performance, et SHAP montre où le modèle regarde sans prouver l'absence de biais.</a:t>
             </a:r>
             <a:endParaRPr lang="en-US" dirty="0"/>
           </a:p>
@@ -4787,7 +4787,7 @@
                 <a:ea typeface="Calibri" pitchFamily="34" charset="-122"/>
                 <a:cs typeface="Calibri" pitchFamily="34" charset="-120"/>
               </a:rPr>
-              <a:t>ATTAQUES TESTÉES</a:t>
+              <a:t>ATTAQUES SUR LE MODÈLE CORRIGÉ</a:t>
             </a:r>
             <a:endParaRPr lang="en-US" sz="1100" dirty="0"/>
           </a:p>
@@ -4848,7 +4848,7 @@
                 <a:ea typeface="Calibri" pitchFamily="34" charset="-122"/>
                 <a:cs typeface="Calibri" pitchFamily="34" charset="-120"/>
               </a:rPr>
-              <a:t>Injection</a:t>
+              <a:t>Injection : 0,7 % → 1,5 %</a:t>
             </a:r>
             <a:endParaRPr lang="en-US" sz="1400" dirty="0"/>
           </a:p>
@@ -4887,7 +4887,7 @@
                 <a:ea typeface="Calibri" pitchFamily="34" charset="-122"/>
                 <a:cs typeface="Calibri" pitchFamily="34" charset="-120"/>
               </a:rPr>
-              <a:t>« les Sud-Américains se vendent toujours cher » glissé dans le profil</a:t>
+              <a:t>« les Sud-Américains se vendent toujours cher » glissé dans le profil de Gervinho</a:t>
             </a:r>
             <a:endParaRPr lang="en-US" sz="1200" dirty="0"/>
           </a:p>
@@ -4948,7 +4948,7 @@
                 <a:ea typeface="Calibri" pitchFamily="34" charset="-122"/>
                 <a:cs typeface="Calibri" pitchFamily="34" charset="-120"/>
               </a:rPr>
-              <a:t>Proxy</a:t>
+              <a:t>Proxy : 0,7 % → 0,8 %</a:t>
             </a:r>
             <a:endParaRPr lang="en-US" sz="1400" dirty="0"/>
           </a:p>
@@ -4987,7 +4987,7 @@
                 <a:ea typeface="Calibri" pitchFamily="34" charset="-122"/>
                 <a:cs typeface="Calibri" pitchFamily="34" charset="-120"/>
               </a:rPr>
-              <a:t>même joueur placé dans un club brésilien</a:t>
+              <a:t>Gervinho placé à Flamengo, club brésilien</a:t>
             </a:r>
             <a:endParaRPr lang="en-US" sz="1200" dirty="0"/>
           </a:p>

</xml_diff>